<commit_message>
docs(sprint_2): fecha o vão vertical do Rigor analítico e dos próximos passos
Conferido exportando o deck em PNG pelo PowerPoint, que é o único jeito de
ver o resultado nesta máquina — não há LibreOffice.

A poda das quatro linhas duplicadas deixou uma faixa morta entre a tabela e o
rodapé; o bloco de fronteira de evidência desce e passa a ler como nota de
pé. No slide novo, os cartões sobravam quatro décimos de polegada vazios e o
painel do argumento, mais de meia.
</commit_message>
<xml_diff>
--- a/docs/entrega_sprint_2/apresentacao/EC_Sprint_2_1TSCO_EvidenciasConstrucao_MedFlow_OmegaUrbanTech.pptx
+++ b/docs/entrega_sprint_2/apresentacao/EC_Sprint_2_1TSCO_EvidenciasConstrucao_MedFlow_OmegaUrbanTech.pptx
@@ -23360,7 +23360,7 @@
         </p:nvSpPr>
         <p:spPr>
           <a:xfrm>
-            <a:off x="548640" y="4224528"/>
+            <a:off x="548640" y="5065776"/>
             <a:ext cx="11091672" cy="7315"/>
           </a:xfrm>
           <a:prstGeom prst="rect">
@@ -23403,7 +23403,7 @@
         </p:nvSpPr>
         <p:spPr>
           <a:xfrm>
-            <a:off x="548640" y="4370832"/>
+            <a:off x="548640" y="5212080"/>
             <a:ext cx="3840480" cy="182880"/>
           </a:xfrm>
           <a:prstGeom prst="rect">
@@ -23442,7 +23442,7 @@
         </p:nvSpPr>
         <p:spPr>
           <a:xfrm>
-            <a:off x="548640" y="4608576"/>
+            <a:off x="548640" y="5449824"/>
             <a:ext cx="5486400" cy="548640"/>
           </a:xfrm>
           <a:prstGeom prst="rect">
@@ -23481,7 +23481,7 @@
         </p:nvSpPr>
         <p:spPr>
           <a:xfrm>
-            <a:off x="6355080" y="4370832"/>
+            <a:off x="6355080" y="5212080"/>
             <a:ext cx="5285232" cy="822960"/>
           </a:xfrm>
           <a:prstGeom prst="rect">
@@ -24976,7 +24976,7 @@
         <p:spPr>
           <a:xfrm>
             <a:off x="548640" y="1874519"/>
-            <a:ext cx="3566160" cy="1691640"/>
+            <a:ext cx="3566160" cy="1417320"/>
           </a:xfrm>
           <a:prstGeom prst="rect">
             <a:avLst/>
@@ -25138,7 +25138,7 @@
         <p:spPr>
           <a:xfrm>
             <a:off x="4315968" y="1874519"/>
-            <a:ext cx="3566160" cy="1691640"/>
+            <a:ext cx="3566160" cy="1417320"/>
           </a:xfrm>
           <a:prstGeom prst="rect">
             <a:avLst/>
@@ -25300,7 +25300,7 @@
         <p:spPr>
           <a:xfrm>
             <a:off x="8083296" y="1874519"/>
-            <a:ext cx="3566160" cy="1691640"/>
+            <a:ext cx="3566160" cy="1417320"/>
           </a:xfrm>
           <a:prstGeom prst="rect">
             <a:avLst/>
@@ -25461,8 +25461,8 @@
         </p:nvSpPr>
         <p:spPr>
           <a:xfrm>
-            <a:off x="548640" y="3840480"/>
-            <a:ext cx="11091672" cy="1783080"/>
+            <a:off x="548640" y="3657600"/>
+            <a:ext cx="11091672" cy="1627632"/>
           </a:xfrm>
           <a:prstGeom prst="rect">
             <a:avLst/>
@@ -25504,7 +25504,7 @@
         </p:nvSpPr>
         <p:spPr>
           <a:xfrm>
-            <a:off x="786384" y="4041648"/>
+            <a:off x="786384" y="3877056"/>
             <a:ext cx="3840480" cy="219456"/>
           </a:xfrm>
           <a:prstGeom prst="rect">
@@ -25543,7 +25543,7 @@
         </p:nvSpPr>
         <p:spPr>
           <a:xfrm>
-            <a:off x="786384" y="4443984"/>
+            <a:off x="786384" y="4297680"/>
             <a:ext cx="329184" cy="201168"/>
           </a:xfrm>
           <a:prstGeom prst="rect">
@@ -25582,7 +25582,7 @@
         </p:nvSpPr>
         <p:spPr>
           <a:xfrm>
-            <a:off x="1152144" y="4425696"/>
+            <a:off x="1152144" y="4279392"/>
             <a:ext cx="3017520" cy="1005840"/>
           </a:xfrm>
           <a:prstGeom prst="rect">
@@ -25602,7 +25602,7 @@
               </a:lnSpc>
             </a:pPr>
             <a:r>
-              <a:rPr sz="880" b="0">
+              <a:rPr sz="919" b="0">
                 <a:solidFill>
                   <a:srgbClr val="2D3748"/>
                 </a:solidFill>
@@ -25621,7 +25621,7 @@
         </p:nvSpPr>
         <p:spPr>
           <a:xfrm>
-            <a:off x="4425696" y="4443984"/>
+            <a:off x="4425696" y="4297680"/>
             <a:ext cx="329184" cy="201168"/>
           </a:xfrm>
           <a:prstGeom prst="rect">
@@ -25660,7 +25660,7 @@
         </p:nvSpPr>
         <p:spPr>
           <a:xfrm>
-            <a:off x="4791456" y="4425696"/>
+            <a:off x="4791456" y="4279392"/>
             <a:ext cx="3017520" cy="1005840"/>
           </a:xfrm>
           <a:prstGeom prst="rect">
@@ -25680,7 +25680,7 @@
               </a:lnSpc>
             </a:pPr>
             <a:r>
-              <a:rPr sz="880" b="0">
+              <a:rPr sz="919" b="0">
                 <a:solidFill>
                   <a:srgbClr val="2D3748"/>
                 </a:solidFill>
@@ -25699,7 +25699,7 @@
         </p:nvSpPr>
         <p:spPr>
           <a:xfrm>
-            <a:off x="8065008" y="4443984"/>
+            <a:off x="8065008" y="4297680"/>
             <a:ext cx="329184" cy="201168"/>
           </a:xfrm>
           <a:prstGeom prst="rect">
@@ -25738,7 +25738,7 @@
         </p:nvSpPr>
         <p:spPr>
           <a:xfrm>
-            <a:off x="8430768" y="4425696"/>
+            <a:off x="8430768" y="4279392"/>
             <a:ext cx="3017520" cy="1005840"/>
           </a:xfrm>
           <a:prstGeom prst="rect">
@@ -25758,7 +25758,7 @@
               </a:lnSpc>
             </a:pPr>
             <a:r>
-              <a:rPr sz="880" b="0">
+              <a:rPr sz="919" b="0">
                 <a:solidFill>
                   <a:srgbClr val="2D3748"/>
                 </a:solidFill>
@@ -25777,7 +25777,7 @@
         </p:nvSpPr>
         <p:spPr>
           <a:xfrm>
-            <a:off x="548640" y="5779008"/>
+            <a:off x="548640" y="5623560"/>
             <a:ext cx="11091672" cy="274320"/>
           </a:xfrm>
           <a:prstGeom prst="rect">

</xml_diff>

<commit_message>
docs(entrega): corrige links e remonta o pacote
</commit_message>
<xml_diff>
--- a/docs/entrega_sprint_2/apresentacao/EC_Sprint_2_1TSCO_EvidenciasConstrucao_MedFlow_OmegaUrbanTech.pptx
+++ b/docs/entrega_sprint_2/apresentacao/EC_Sprint_2_1TSCO_EvidenciasConstrucao_MedFlow_OmegaUrbanTech.pptx
@@ -23410,7 +23410,65 @@
                 <a:ea typeface="Calibri" pitchFamily="34" charset="-122"/>
                 <a:cs typeface="Calibri" pitchFamily="34" charset="-120"/>
               </a:rPr>
-              <a:t>Vídeo pitch: youtu.be/Hum7fgOejyI    ·    github.com/Lucas-D-S-1/medflow    ·    lucas-d-s-1.github.io/medflow</a:t>
+              <a:t xml:space="preserve">Vídeo pitch: </a:t>
+            </a:r>
+            <a:r>
+              <a:rPr lang="en-US" sz="950" dirty="0">
+                <a:solidFill>
+                  <a:srgbClr val="37AB94"/>
+                </a:solidFill>
+                <a:latin typeface="Aptos" pitchFamily="34" charset="0"/>
+                <a:ea typeface="Calibri" pitchFamily="34" charset="-122"/>
+                <a:cs typeface="Calibri" pitchFamily="34" charset="-120"/>
+                <a:hlinkClick r:id="rId4"/>
+              </a:rPr>
+              <a:t>youtu.be/Hum7fgOejyI</a:t>
+            </a:r>
+            <a:r>
+              <a:rPr lang="en-US" sz="950" dirty="0">
+                <a:solidFill>
+                  <a:srgbClr val="37AB94"/>
+                </a:solidFill>
+                <a:latin typeface="Aptos" pitchFamily="34" charset="0"/>
+                <a:ea typeface="Calibri" pitchFamily="34" charset="-122"/>
+                <a:cs typeface="Calibri" pitchFamily="34" charset="-120"/>
+              </a:rPr>
+              <a:t xml:space="preserve">    ·    </a:t>
+            </a:r>
+            <a:r>
+              <a:rPr lang="en-US" sz="950" dirty="0">
+                <a:solidFill>
+                  <a:srgbClr val="37AB94"/>
+                </a:solidFill>
+                <a:latin typeface="Aptos" pitchFamily="34" charset="0"/>
+                <a:ea typeface="Calibri" pitchFamily="34" charset="-122"/>
+                <a:cs typeface="Calibri" pitchFamily="34" charset="-120"/>
+                <a:hlinkClick r:id="rId5"/>
+              </a:rPr>
+              <a:t>github.com/Lucas-D-S-1/medflow</a:t>
+            </a:r>
+            <a:r>
+              <a:rPr lang="en-US" sz="950" dirty="0">
+                <a:solidFill>
+                  <a:srgbClr val="37AB94"/>
+                </a:solidFill>
+                <a:latin typeface="Aptos" pitchFamily="34" charset="0"/>
+                <a:ea typeface="Calibri" pitchFamily="34" charset="-122"/>
+                <a:cs typeface="Calibri" pitchFamily="34" charset="-120"/>
+              </a:rPr>
+              <a:t xml:space="preserve">    ·    </a:t>
+            </a:r>
+            <a:r>
+              <a:rPr lang="en-US" sz="950" dirty="0">
+                <a:solidFill>
+                  <a:srgbClr val="37AB94"/>
+                </a:solidFill>
+                <a:latin typeface="Aptos" pitchFamily="34" charset="0"/>
+                <a:ea typeface="Calibri" pitchFamily="34" charset="-122"/>
+                <a:cs typeface="Calibri" pitchFamily="34" charset="-120"/>
+                <a:hlinkClick r:id="rId6"/>
+              </a:rPr>
+              <a:t>lucas-d-s-1.github.io/medflow</a:t>
             </a:r>
             <a:endParaRPr lang="en-US" sz="950" dirty="0"/>
           </a:p>

</xml_diff>